<commit_message>
sd-02-013, sd-02-015: qualify queue retention and duplicate charges
The queue keeps a notification through a channel outage only when it is
durable, deletes after delivery and retries. A transaction makes one
write atomic but does not stop a retried payment being recorded twice;
that needs an idempotency key or a unique constraint. Lessons, figure
and decks (PPTX re-exported) updated.

Co-Authored-By: Claude Opus 5.5 <noreply@anthropic.com>
Claude-Session: https://claude.ai/code/session_01McBLtMnJbTnB94NeVs8a2V
</commit_message>
<xml_diff>
--- a/system-design-101/vi/lessons/sd-02-013/slides/sd-02-013.pptx
+++ b/system-design-101/vi/lessons/sd-02-013/slides/sd-02-013.pptx
@@ -13556,7 +13556,18 @@
                 <a:ea typeface="Be Vietnam Pro" pitchFamily="34" charset="-122"/>
                 <a:cs typeface="Be Vietnam Pro" pitchFamily="34" charset="-120"/>
               </a:rPr>
-              <a:t> nằm chờ,</a:t>
+              <a:t> có</a:t>
+            </a:r>
+            <a:r>
+              <a:rPr lang="en-US" sz="2850" dirty="0" spc="0" kern="0">
+                <a:solidFill>
+                  <a:srgbClr val="E4E1D8"/>
+                </a:solidFill>
+                <a:latin typeface="Be Vietnam Pro" pitchFamily="34" charset="0"/>
+                <a:ea typeface="Be Vietnam Pro" pitchFamily="34" charset="-122"/>
+                <a:cs typeface="Be Vietnam Pro" pitchFamily="34" charset="-120"/>
+              </a:rPr>
+              <a:t> thể</a:t>
             </a:r>
             <a:r>
               <a:rPr lang="en-US" sz="2850" dirty="0" spc="-2" kern="0">
@@ -13567,10 +13578,10 @@
                 <a:ea typeface="Be Vietnam Pro" pitchFamily="34" charset="-122"/>
                 <a:cs typeface="Be Vietnam Pro" pitchFamily="34" charset="-120"/>
               </a:rPr>
-              <a:t> không</a:t>
-            </a:r>
-            <a:r>
-              <a:rPr lang="en-US" sz="2850" dirty="0" spc="-12" kern="0">
+              <a:t> nằm</a:t>
+            </a:r>
+            <a:r>
+              <a:rPr lang="en-US" sz="2850" dirty="0" spc="0" kern="0">
                 <a:solidFill>
                   <a:srgbClr val="E4E1D8"/>
                 </a:solidFill>
@@ -13578,7 +13589,84 @@
                 <a:ea typeface="Be Vietnam Pro" pitchFamily="34" charset="-122"/>
                 <a:cs typeface="Be Vietnam Pro" pitchFamily="34" charset="-120"/>
               </a:rPr>
-              <a:t> mất.</a:t>
+              <a:t> chờ, nếu</a:t>
+            </a:r>
+            <a:r>
+              <a:rPr lang="en-US" sz="2850" dirty="0" spc="-1" kern="0">
+                <a:solidFill>
+                  <a:srgbClr val="E4E1D8"/>
+                </a:solidFill>
+                <a:latin typeface="Be Vietnam Pro" pitchFamily="34" charset="0"/>
+                <a:ea typeface="Be Vietnam Pro" pitchFamily="34" charset="-122"/>
+                <a:cs typeface="Be Vietnam Pro" pitchFamily="34" charset="-120"/>
+              </a:rPr>
+              <a:t> hàng</a:t>
+            </a:r>
+            <a:r>
+              <a:rPr lang="en-US" sz="2850" dirty="0" spc="15" kern="0">
+                <a:solidFill>
+                  <a:srgbClr val="E4E1D8"/>
+                </a:solidFill>
+                <a:latin typeface="Be Vietnam Pro" pitchFamily="34" charset="0"/>
+                <a:ea typeface="Be Vietnam Pro" pitchFamily="34" charset="-122"/>
+                <a:cs typeface="Be Vietnam Pro" pitchFamily="34" charset="-120"/>
+              </a:rPr>
+              <a:t> đợi</a:t>
+            </a:r>
+            <a:r>
+              <a:rPr lang="en-US" sz="2850" dirty="0" spc="24" kern="0">
+                <a:solidFill>
+                  <a:srgbClr val="E4E1D8"/>
+                </a:solidFill>
+                <a:latin typeface="Be Vietnam Pro" pitchFamily="34" charset="0"/>
+                <a:ea typeface="Be Vietnam Pro" pitchFamily="34" charset="-122"/>
+                <a:cs typeface="Be Vietnam Pro" pitchFamily="34" charset="-120"/>
+              </a:rPr>
+              <a:t> lưu</a:t>
+            </a:r>
+            <a:r>
+              <a:rPr lang="en-US" sz="2850" dirty="0" spc="-5" kern="0">
+                <a:solidFill>
+                  <a:srgbClr val="E4E1D8"/>
+                </a:solidFill>
+                <a:latin typeface="Be Vietnam Pro" pitchFamily="34" charset="0"/>
+                <a:ea typeface="Be Vietnam Pro" pitchFamily="34" charset="-122"/>
+                <a:cs typeface="Be Vietnam Pro" pitchFamily="34" charset="-120"/>
+              </a:rPr>
+              <a:t> bền</a:t>
+            </a:r>
+            <a:r>
+              <a:rPr lang="en-US" sz="2850" dirty="0" spc="-16" kern="0">
+                <a:solidFill>
+                  <a:srgbClr val="E4E1D8"/>
+                </a:solidFill>
+                <a:latin typeface="Be Vietnam Pro" pitchFamily="34" charset="0"/>
+                <a:ea typeface="Be Vietnam Pro" pitchFamily="34" charset="-122"/>
+                <a:cs typeface="Be Vietnam Pro" pitchFamily="34" charset="-120"/>
+              </a:rPr>
+              <a:t> và</a:t>
+            </a:r>
+            <a:r>
+              <a:rPr lang="en-US" sz="2850" dirty="0" spc="-1" kern="0">
+                <a:solidFill>
+                  <a:srgbClr val="E4E1D8"/>
+                </a:solidFill>
+                <a:latin typeface="Be Vietnam Pro" pitchFamily="34" charset="0"/>
+                <a:ea typeface="Be Vietnam Pro" pitchFamily="34" charset="-122"/>
+                <a:cs typeface="Be Vietnam Pro" pitchFamily="34" charset="-120"/>
+              </a:rPr>
+              <a:t> có thử</a:t>
+            </a:r>
+            <a:r>
+              <a:rPr lang="en-US" sz="2850" dirty="0" spc="2" kern="0">
+                <a:solidFill>
+                  <a:srgbClr val="E4E1D8"/>
+                </a:solidFill>
+                <a:latin typeface="Be Vietnam Pro" pitchFamily="34" charset="0"/>
+                <a:ea typeface="Be Vietnam Pro" pitchFamily="34" charset="-122"/>
+                <a:cs typeface="Be Vietnam Pro" pitchFamily="34" charset="-120"/>
+              </a:rPr>
+              <a:t> lại.</a:t>
             </a:r>
             <a:endParaRPr lang="en-US" sz="2850" dirty="0"/>
           </a:p>

</xml_diff>